<commit_message>
Update presentation file to FINAL v0
Co-Authored-By: Claude Sonnet 4.6 <noreply@anthropic.com>
</commit_message>
<xml_diff>
--- a/public/briefings/norfolk-ai-impact-board-presentation.pptx
+++ b/public/briefings/norfolk-ai-impact-board-presentation.pptx
@@ -1312,11 +1312,10 @@
           <a:bodyPr wrap="square" lIns="0" tIns="0" rIns="0" bIns="0" rtlCol="0" anchor="ctr"/>
           <a:lstStyle/>
           <a:p>
-            <a:pPr marL="0" indent="0">
+            <a:pPr>
               <a:lnSpc>
                 <a:spcPct val="135000"/>
               </a:lnSpc>
-              <a:buNone/>
             </a:pPr>
             <a:r>
               <a:rPr lang="en-US" sz="1100" i="1" dirty="0">
@@ -1332,11 +1331,10 @@
             <a:endParaRPr lang="en-US" sz="1100" dirty="0"/>
           </a:p>
           <a:p>
-            <a:pPr marL="0" indent="0">
+            <a:pPr>
               <a:lnSpc>
                 <a:spcPct val="135000"/>
               </a:lnSpc>
-              <a:buNone/>
             </a:pPr>
             <a:r>
               <a:rPr lang="en-US" sz="1100" i="1" dirty="0">
@@ -1347,16 +1345,37 @@
                 <a:ea typeface="Calibri" pitchFamily="34" charset="-122"/>
                 <a:cs typeface="Calibri" pitchFamily="34" charset="-120"/>
               </a:rPr>
-              <a:t>Chambers of Commerce leadership and</a:t>
+              <a:t>b</a:t>
+            </a:r>
+            <a:r>
+              <a:rPr lang="en-US" sz="1100" i="1">
+                <a:solidFill>
+                  <a:srgbClr val="8A9A90"/>
+                </a:solidFill>
+                <a:latin typeface="Calibri" pitchFamily="34" charset="0"/>
+                <a:ea typeface="Calibri" pitchFamily="34" charset="-122"/>
+                <a:cs typeface="Calibri" pitchFamily="34" charset="-120"/>
+              </a:rPr>
+              <a:t>usiness </a:t>
+            </a:r>
+            <a:r>
+              <a:rPr lang="en-US" sz="1100" i="1" dirty="0">
+                <a:solidFill>
+                  <a:srgbClr val="8A9A90"/>
+                </a:solidFill>
+                <a:latin typeface="Calibri" pitchFamily="34" charset="0"/>
+                <a:ea typeface="Calibri" pitchFamily="34" charset="-122"/>
+                <a:cs typeface="Calibri" pitchFamily="34" charset="-120"/>
+              </a:rPr>
+              <a:t>and civic leadership and</a:t>
             </a:r>
             <a:endParaRPr lang="en-US" sz="1100" dirty="0"/>
           </a:p>
           <a:p>
-            <a:pPr marL="0" indent="0">
+            <a:pPr>
               <a:lnSpc>
                 <a:spcPct val="135000"/>
               </a:lnSpc>
-              <a:buNone/>
             </a:pPr>
             <a:r>
               <a:rPr lang="en-US" sz="1100" i="1" dirty="0">

</xml_diff>